<commit_message>
Push all latest migrated changes from Unite msc
</commit_message>
<xml_diff>
--- a/programs/leadership-updates/2026-08-am-squad-leadership-update/deliverables/AM-Squad-Leadership-Executive-Glimpse-Aug2026.pptx
+++ b/programs/leadership-updates/2026-08-am-squad-leadership-update/deliverables/AM-Squad-Leadership-Executive-Glimpse-Aug2026.pptx
@@ -3887,7 +3887,7 @@
         <p:spPr>
           <a:xfrm>
             <a:off x="320040" y="868680"/>
-            <a:ext cx="8503920" cy="5029200"/>
+            <a:ext cx="8503920" cy="4892040"/>
           </a:xfrm>
           <a:prstGeom prst="roundRect">
             <a:avLst/>
@@ -3930,7 +3930,7 @@
         <p:spPr>
           <a:xfrm>
             <a:off x="320040" y="868680"/>
-            <a:ext cx="54864" cy="5029200"/>
+            <a:ext cx="54864" cy="4892040"/>
           </a:xfrm>
           <a:prstGeom prst="rect">
             <a:avLst/>
@@ -4008,7 +4008,7 @@
         <p:spPr>
           <a:xfrm>
             <a:off x="502920" y="1307592"/>
-            <a:ext cx="8229600" cy="4526280"/>
+            <a:ext cx="8229600" cy="4389120"/>
           </a:xfrm>
           <a:prstGeom prst="rect">
             <a:avLst/>
@@ -4090,8 +4090,8 @@
         </p:nvSpPr>
         <p:spPr>
           <a:xfrm>
-            <a:off x="0" y="6510528"/>
-            <a:ext cx="9144000" cy="347472"/>
+            <a:off x="0" y="6291072"/>
+            <a:ext cx="9144000" cy="566928"/>
           </a:xfrm>
           <a:prstGeom prst="rect">
             <a:avLst/>
@@ -4133,7 +4133,7 @@
         </p:nvSpPr>
         <p:spPr>
           <a:xfrm>
-            <a:off x="0" y="6510528"/>
+            <a:off x="0" y="6291072"/>
             <a:ext cx="9144000" cy="18288"/>
           </a:xfrm>
           <a:prstGeom prst="rect">
@@ -4176,8 +4176,8 @@
         </p:nvSpPr>
         <p:spPr>
           <a:xfrm>
-            <a:off x="384048" y="6583680"/>
-            <a:ext cx="7772400" cy="228600"/>
+            <a:off x="384048" y="6355080"/>
+            <a:ext cx="8046720" cy="256032"/>
           </a:xfrm>
           <a:prstGeom prst="rect">
             <a:avLst/>
@@ -4191,14 +4191,14 @@
           <a:lstStyle/>
           <a:p>
             <a:pPr>
-              <a:defRPr sz="800">
+              <a:defRPr sz="750" i="1">
                 <a:solidFill>
                   <a:srgbClr val="64748B"/>
                 </a:solidFill>
               </a:defRPr>
             </a:pPr>
             <a:r>
-              <a:t>Full detail: AM-Squad-Leadership-Detailed-Modern-Aug2026.pptx</a:t>
+              <a:t>Note: Team formed Q2 2025; Apr–Aug is the 5-month delivery window on top of ~12 months of build.</a:t>
             </a:r>
           </a:p>
         </p:txBody>
@@ -4211,8 +4211,8 @@
         </p:nvSpPr>
         <p:spPr>
           <a:xfrm>
-            <a:off x="8412480" y="6583680"/>
-            <a:ext cx="548640" cy="228600"/>
+            <a:off x="384048" y="6592824"/>
+            <a:ext cx="7772400" cy="201168"/>
           </a:xfrm>
           <a:prstGeom prst="rect">
             <a:avLst/>
@@ -4225,8 +4225,43 @@
           </a:bodyPr>
           <a:lstStyle/>
           <a:p>
+            <a:pPr>
+              <a:defRPr sz="750">
+                <a:solidFill>
+                  <a:srgbClr val="64748B"/>
+                </a:solidFill>
+              </a:defRPr>
+            </a:pPr>
+            <a:r>
+              <a:t>Full detail: AM-Squad-Leadership-Detailed-Modern-Aug2026.pptx</a:t>
+            </a:r>
+          </a:p>
+        </p:txBody>
+      </p:sp>
+      <p:sp>
+        <p:nvSpPr>
+          <p:cNvPr id="15" name="TextBox 14"/>
+          <p:cNvSpPr txBox="1"/>
+          <p:nvPr/>
+        </p:nvSpPr>
+        <p:spPr>
+          <a:xfrm>
+            <a:off x="8412480" y="6592824"/>
+            <a:ext cx="548640" cy="201168"/>
+          </a:xfrm>
+          <a:prstGeom prst="rect">
+            <a:avLst/>
+          </a:prstGeom>
+          <a:noFill/>
+        </p:spPr>
+        <p:txBody>
+          <a:bodyPr wrap="none">
+            <a:spAutoFit/>
+          </a:bodyPr>
+          <a:lstStyle/>
+          <a:p>
             <a:pPr algn="r">
-              <a:defRPr sz="900">
+              <a:defRPr sz="800">
                 <a:solidFill>
                   <a:srgbClr val="64748B"/>
                 </a:solidFill>
@@ -4797,7 +4832,7 @@
               </a:defRPr>
             </a:pPr>
             <a:r>
-              <a:t>116</a:t>
+              <a:t>121</a:t>
             </a:r>
           </a:p>
         </p:txBody>
@@ -5144,7 +5179,7 @@
               </a:defRPr>
             </a:pPr>
             <a:r>
-              <a:t>V2 nightly</a:t>
+              <a:t>V2 Stage1 nightly</a:t>
             </a:r>
           </a:p>
         </p:txBody>
@@ -5214,7 +5249,7 @@
               </a:defRPr>
             </a:pPr>
             <a:r>
-              <a:t>Test methods · Stage1</a:t>
+              <a:t>Aug 4 · ~12 mo build</a:t>
             </a:r>
           </a:p>
         </p:txBody>
@@ -5335,7 +5370,7 @@
               </a:defRPr>
             </a:pPr>
             <a:r>
-              <a:t>V3 nightly</a:t>
+              <a:t>V3 Stage1 nightly</a:t>
             </a:r>
           </a:p>
         </p:txBody>
@@ -5405,7 +5440,7 @@
               </a:defRPr>
             </a:pPr>
             <a:r>
-              <a:t>Test methods · GitLab</a:t>
+              <a:t>GitLab · Aug 4</a:t>
             </a:r>
           </a:p>
         </p:txBody>
@@ -6182,8 +6217,8 @@
         </p:nvSpPr>
         <p:spPr>
           <a:xfrm>
-            <a:off x="320040" y="3657600"/>
-            <a:ext cx="8503920" cy="457200"/>
+            <a:off x="320040" y="3611880"/>
+            <a:ext cx="8503920" cy="502920"/>
           </a:xfrm>
           <a:prstGeom prst="rect">
             <a:avLst/>
@@ -6197,14 +6232,14 @@
           <a:lstStyle/>
           <a:p>
             <a:pPr>
-              <a:defRPr sz="900" i="1">
+              <a:defRPr sz="850" i="1">
                 <a:solidFill>
                   <a:srgbClr val="64748B"/>
                 </a:solidFill>
               </a:defRPr>
             </a:pPr>
             <a:r>
-              <a:t>Monthly delivery chart = period velocity. Scorecard = cumulative nightly inventory (~12 mo since Q2 2025).</a:t>
+              <a:t>V2/V3 = Stage1 nightly snapshots only (built since Q2 2025). Excludes smoke, Stage 2/5, integrations, +33 CSR Actions.</a:t>
             </a:r>
           </a:p>
         </p:txBody>
@@ -6217,8 +6252,8 @@
         </p:nvSpPr>
         <p:spPr>
           <a:xfrm>
-            <a:off x="320040" y="4160520"/>
-            <a:ext cx="8503920" cy="2057400"/>
+            <a:off x="320040" y="4114800"/>
+            <a:ext cx="8503920" cy="1874519"/>
           </a:xfrm>
           <a:prstGeom prst="roundRect">
             <a:avLst/>
@@ -6260,8 +6295,8 @@
         </p:nvSpPr>
         <p:spPr>
           <a:xfrm>
-            <a:off x="320040" y="4160520"/>
-            <a:ext cx="54864" cy="2057400"/>
+            <a:off x="320040" y="4114800"/>
+            <a:ext cx="54864" cy="1874519"/>
           </a:xfrm>
           <a:prstGeom prst="rect">
             <a:avLst/>
@@ -6303,7 +6338,7 @@
         </p:nvSpPr>
         <p:spPr>
           <a:xfrm>
-            <a:off x="502920" y="4270248"/>
+            <a:off x="502920" y="4224528"/>
             <a:ext cx="8229600" cy="320040"/>
           </a:xfrm>
           <a:prstGeom prst="rect">
@@ -6338,8 +6373,8 @@
         </p:nvSpPr>
         <p:spPr>
           <a:xfrm>
-            <a:off x="502920" y="4599432"/>
-            <a:ext cx="8229600" cy="1554480"/>
+            <a:off x="502920" y="4553712"/>
+            <a:ext cx="8229600" cy="1371599"/>
           </a:xfrm>
           <a:prstGeom prst="rect">
             <a:avLst/>
@@ -6363,7 +6398,7 @@
               </a:defRPr>
             </a:pPr>
             <a:r>
-              <a:t>• We are NOT claiming 1,212 + 592 + 442 test cases — different metrics (period delivery vs inventory).</a:t>
+              <a:t>• 592 V2 + 442 V3 = Stage1 nightly snapshots (Aug 4) — built since Q2 2025, not in Apr–Aug alone.</a:t>
             </a:r>
           </a:p>
           <a:p>
@@ -6378,7 +6413,7 @@
               </a:defRPr>
             </a:pPr>
             <a:r>
-              <a:t>• ~1,212 is estimated new coverage closed in Apr–Aug from 225 Jira stories.</a:t>
+              <a:t>• Excludes smoke (Stage 2/5), integration suites, and +33 CSR Actions pending wire — more coverage exists.</a:t>
             </a:r>
           </a:p>
           <a:p>
@@ -6393,7 +6428,7 @@
               </a:defRPr>
             </a:pPr>
             <a:r>
-              <a:t>• 592 V2 + 442 V3 + 323 perf = what runs in nightly regression today, built over ~1 year.</a:t>
+              <a:t>• We are NOT claiming 1,212 + 592 + 442 — period delivery vs inventory are different metrics.</a:t>
             </a:r>
           </a:p>
           <a:p>
@@ -6408,6 +6443,21 @@
               </a:defRPr>
             </a:pPr>
             <a:r>
+              <a:t>• ~1,212 estimated new coverage in Apr–Aug from 225 Jira stories; nightly totals include pre-April foundation.</a:t>
+            </a:r>
+          </a:p>
+          <a:p>
+            <a:pPr>
+              <a:spcAft>
+                <a:spcPts val="500"/>
+              </a:spcAft>
+              <a:defRPr sz="1000">
+                <a:solidFill>
+                  <a:srgbClr val="1A2332"/>
+                </a:solidFill>
+              </a:defRPr>
+            </a:pPr>
+            <a:r>
               <a:t>• Apr–Aug shows acceleration (MSC API sprint Jun–Jul), not greenfield from zero.</a:t>
             </a:r>
           </a:p>
@@ -6421,8 +6471,8 @@
         </p:nvSpPr>
         <p:spPr>
           <a:xfrm>
-            <a:off x="0" y="6510528"/>
-            <a:ext cx="9144000" cy="347472"/>
+            <a:off x="0" y="6291072"/>
+            <a:ext cx="9144000" cy="566928"/>
           </a:xfrm>
           <a:prstGeom prst="rect">
             <a:avLst/>
@@ -6464,7 +6514,7 @@
         </p:nvSpPr>
         <p:spPr>
           <a:xfrm>
-            <a:off x="0" y="6510528"/>
+            <a:off x="0" y="6291072"/>
             <a:ext cx="9144000" cy="18288"/>
           </a:xfrm>
           <a:prstGeom prst="rect">
@@ -6507,8 +6557,8 @@
         </p:nvSpPr>
         <p:spPr>
           <a:xfrm>
-            <a:off x="384048" y="6583680"/>
-            <a:ext cx="7772400" cy="228600"/>
+            <a:off x="384048" y="6355080"/>
+            <a:ext cx="8046720" cy="256032"/>
           </a:xfrm>
           <a:prstGeom prst="rect">
             <a:avLst/>
@@ -6522,14 +6572,14 @@
           <a:lstStyle/>
           <a:p>
             <a:pPr>
-              <a:defRPr sz="800">
+              <a:defRPr sz="750" i="1">
                 <a:solidFill>
                   <a:srgbClr val="64748B"/>
                 </a:solidFill>
               </a:defRPr>
             </a:pPr>
             <a:r>
-              <a:t>Sources: GitLab MR export · Jira AMSQUAD · Jenkins/GitLab nightly logs</a:t>
+              <a:t>Note: 592 V2 and 442 V3 are Stage1 nightly snapshots only — accumulated since Q2 2025, not built in Apr–Aug alone. Smoke (Stage 2/5), integrations, and +33 CSR Actions are additional coverage and are not added to these totals.</a:t>
             </a:r>
           </a:p>
         </p:txBody>
@@ -6542,8 +6592,8 @@
         </p:nvSpPr>
         <p:spPr>
           <a:xfrm>
-            <a:off x="8412480" y="6583680"/>
-            <a:ext cx="548640" cy="228600"/>
+            <a:off x="384048" y="6592824"/>
+            <a:ext cx="7772400" cy="201168"/>
           </a:xfrm>
           <a:prstGeom prst="rect">
             <a:avLst/>
@@ -6556,8 +6606,43 @@
           </a:bodyPr>
           <a:lstStyle/>
           <a:p>
+            <a:pPr>
+              <a:defRPr sz="750">
+                <a:solidFill>
+                  <a:srgbClr val="64748B"/>
+                </a:solidFill>
+              </a:defRPr>
+            </a:pPr>
+            <a:r>
+              <a:t>Sources: GitLab MR export · Jira AMSQUAD · Jenkins/GitLab nightly logs</a:t>
+            </a:r>
+          </a:p>
+        </p:txBody>
+      </p:sp>
+      <p:sp>
+        <p:nvSpPr>
+          <p:cNvPr id="56" name="TextBox 55"/>
+          <p:cNvSpPr txBox="1"/>
+          <p:nvPr/>
+        </p:nvSpPr>
+        <p:spPr>
+          <a:xfrm>
+            <a:off x="8412480" y="6592824"/>
+            <a:ext cx="548640" cy="201168"/>
+          </a:xfrm>
+          <a:prstGeom prst="rect">
+            <a:avLst/>
+          </a:prstGeom>
+          <a:noFill/>
+        </p:spPr>
+        <p:txBody>
+          <a:bodyPr wrap="none">
+            <a:spAutoFit/>
+          </a:bodyPr>
+          <a:lstStyle/>
+          <a:p>
             <a:pPr algn="r">
-              <a:defRPr sz="900">
+              <a:defRPr sz="800">
                 <a:solidFill>
                   <a:srgbClr val="64748B"/>
                 </a:solidFill>
@@ -6836,7 +6921,7 @@
         <p:spPr>
           <a:xfrm>
             <a:off x="5349240" y="868680"/>
-            <a:ext cx="3474720" cy="5349240"/>
+            <a:ext cx="3474720" cy="5074920"/>
           </a:xfrm>
           <a:prstGeom prst="roundRect">
             <a:avLst/>
@@ -6879,7 +6964,7 @@
         <p:spPr>
           <a:xfrm>
             <a:off x="5349240" y="868680"/>
-            <a:ext cx="54864" cy="5349240"/>
+            <a:ext cx="54864" cy="5074920"/>
           </a:xfrm>
           <a:prstGeom prst="rect">
             <a:avLst/>
@@ -6957,7 +7042,7 @@
         <p:spPr>
           <a:xfrm>
             <a:off x="5532120" y="1307592"/>
-            <a:ext cx="3200400" cy="4846320"/>
+            <a:ext cx="3200400" cy="4572000"/>
           </a:xfrm>
           <a:prstGeom prst="rect">
             <a:avLst/>
@@ -6981,7 +7066,7 @@
               </a:defRPr>
             </a:pPr>
             <a:r>
-              <a:t>• 116 merges to main across automation, prime-test-automation, and api-test-automation</a:t>
+              <a:t>• 121 merges to main across automation, prime-test-automation, and api-test-automation</a:t>
             </a:r>
           </a:p>
           <a:p>
@@ -6996,7 +7081,7 @@
               </a:defRPr>
             </a:pPr>
             <a:r>
-              <a:t>• Peak Jun–Jul during Unite MSC API sprint (19 + 27 API MRs)</a:t>
+              <a:t>• July peak: 38 merges during Unite MSC API sprint</a:t>
             </a:r>
           </a:p>
           <a:p>
@@ -7024,8 +7109,8 @@
         </p:nvSpPr>
         <p:spPr>
           <a:xfrm>
-            <a:off x="0" y="6510528"/>
-            <a:ext cx="9144000" cy="347472"/>
+            <a:off x="0" y="6291072"/>
+            <a:ext cx="9144000" cy="566928"/>
           </a:xfrm>
           <a:prstGeom prst="rect">
             <a:avLst/>
@@ -7067,7 +7152,7 @@
         </p:nvSpPr>
         <p:spPr>
           <a:xfrm>
-            <a:off x="0" y="6510528"/>
+            <a:off x="0" y="6291072"/>
             <a:ext cx="9144000" cy="18288"/>
           </a:xfrm>
           <a:prstGeom prst="rect">
@@ -7110,8 +7195,8 @@
         </p:nvSpPr>
         <p:spPr>
           <a:xfrm>
-            <a:off x="384048" y="6583680"/>
-            <a:ext cx="7772400" cy="228600"/>
+            <a:off x="384048" y="6355080"/>
+            <a:ext cx="8046720" cy="256032"/>
           </a:xfrm>
           <a:prstGeom prst="rect">
             <a:avLst/>
@@ -7125,14 +7210,14 @@
           <a:lstStyle/>
           <a:p>
             <a:pPr>
-              <a:defRPr sz="800">
+              <a:defRPr sz="750" i="1">
                 <a:solidFill>
                   <a:srgbClr val="64748B"/>
                 </a:solidFill>
               </a:defRPr>
             </a:pPr>
             <a:r>
-              <a:t>GitLab MR export · Apr 1 – Aug 4, 2026</a:t>
+              <a:t>Note: July = 38 merges (highest month). Counts merged code changes, not test cases or story points.</a:t>
             </a:r>
           </a:p>
         </p:txBody>
@@ -7145,8 +7230,8 @@
         </p:nvSpPr>
         <p:spPr>
           <a:xfrm>
-            <a:off x="8412480" y="6583680"/>
-            <a:ext cx="548640" cy="228600"/>
+            <a:off x="384048" y="6592824"/>
+            <a:ext cx="7772400" cy="201168"/>
           </a:xfrm>
           <a:prstGeom prst="rect">
             <a:avLst/>
@@ -7159,8 +7244,43 @@
           </a:bodyPr>
           <a:lstStyle/>
           <a:p>
+            <a:pPr>
+              <a:defRPr sz="750">
+                <a:solidFill>
+                  <a:srgbClr val="64748B"/>
+                </a:solidFill>
+              </a:defRPr>
+            </a:pPr>
+            <a:r>
+              <a:t>GitLab MR export · Apr 1 – Aug 4, 2026</a:t>
+            </a:r>
+          </a:p>
+        </p:txBody>
+      </p:sp>
+      <p:sp>
+        <p:nvSpPr>
+          <p:cNvPr id="16" name="TextBox 15"/>
+          <p:cNvSpPr txBox="1"/>
+          <p:nvPr/>
+        </p:nvSpPr>
+        <p:spPr>
+          <a:xfrm>
+            <a:off x="8412480" y="6592824"/>
+            <a:ext cx="548640" cy="201168"/>
+          </a:xfrm>
+          <a:prstGeom prst="rect">
+            <a:avLst/>
+          </a:prstGeom>
+          <a:noFill/>
+        </p:spPr>
+        <p:txBody>
+          <a:bodyPr wrap="none">
+            <a:spAutoFit/>
+          </a:bodyPr>
+          <a:lstStyle/>
+          <a:p>
             <a:pPr algn="r">
-              <a:defRPr sz="900">
+              <a:defRPr sz="800">
                 <a:solidFill>
                   <a:srgbClr val="64748B"/>
                 </a:solidFill>
@@ -7439,7 +7559,7 @@
         <p:spPr>
           <a:xfrm>
             <a:off x="5349240" y="868680"/>
-            <a:ext cx="3474720" cy="5349240"/>
+            <a:ext cx="3474720" cy="5074920"/>
           </a:xfrm>
           <a:prstGeom prst="roundRect">
             <a:avLst/>
@@ -7482,7 +7602,7 @@
         <p:spPr>
           <a:xfrm>
             <a:off x="5349240" y="868680"/>
-            <a:ext cx="54864" cy="5349240"/>
+            <a:ext cx="54864" cy="5074920"/>
           </a:xfrm>
           <a:prstGeom prst="rect">
             <a:avLst/>
@@ -7560,7 +7680,7 @@
         <p:spPr>
           <a:xfrm>
             <a:off x="5532120" y="1307592"/>
-            <a:ext cx="3200400" cy="4846320"/>
+            <a:ext cx="3200400" cy="4572000"/>
           </a:xfrm>
           <a:prstGeom prst="rect">
             <a:avLst/>
@@ -7629,7 +7749,7 @@
               </a:defRPr>
             </a:pPr>
             <a:r>
-              <a:t>• Pre-Apr foundation in nightly inventory — this chart shows when work landed</a:t>
+              <a:t>• Pre-Apr foundation sits in nightly inventory — chart shows when work landed</a:t>
             </a:r>
           </a:p>
         </p:txBody>
@@ -7642,8 +7762,8 @@
         </p:nvSpPr>
         <p:spPr>
           <a:xfrm>
-            <a:off x="0" y="6510528"/>
-            <a:ext cx="9144000" cy="347472"/>
+            <a:off x="0" y="6291072"/>
+            <a:ext cx="9144000" cy="566928"/>
           </a:xfrm>
           <a:prstGeom prst="rect">
             <a:avLst/>
@@ -7685,7 +7805,7 @@
         </p:nvSpPr>
         <p:spPr>
           <a:xfrm>
-            <a:off x="0" y="6510528"/>
+            <a:off x="0" y="6291072"/>
             <a:ext cx="9144000" cy="18288"/>
           </a:xfrm>
           <a:prstGeom prst="rect">
@@ -7728,8 +7848,8 @@
         </p:nvSpPr>
         <p:spPr>
           <a:xfrm>
-            <a:off x="384048" y="6583680"/>
-            <a:ext cx="7772400" cy="228600"/>
+            <a:off x="384048" y="6355080"/>
+            <a:ext cx="8046720" cy="256032"/>
           </a:xfrm>
           <a:prstGeom prst="rect">
             <a:avLst/>
@@ -7743,14 +7863,14 @@
           <a:lstStyle/>
           <a:p>
             <a:pPr>
-              <a:defRPr sz="800">
+              <a:defRPr sz="750" i="1">
                 <a:solidFill>
                   <a:srgbClr val="64748B"/>
                 </a:solidFill>
               </a:defRPr>
             </a:pPr>
             <a:r>
-              <a:t>Jira AMSQUAD Sprints 26.04–26.12 · period delivery estimate</a:t>
+              <a:t>Note: Period velocity only — do not add ~1,212 to scorecard inventory (592+442+323).</a:t>
             </a:r>
           </a:p>
         </p:txBody>
@@ -7763,8 +7883,8 @@
         </p:nvSpPr>
         <p:spPr>
           <a:xfrm>
-            <a:off x="8412480" y="6583680"/>
-            <a:ext cx="548640" cy="228600"/>
+            <a:off x="384048" y="6592824"/>
+            <a:ext cx="7772400" cy="201168"/>
           </a:xfrm>
           <a:prstGeom prst="rect">
             <a:avLst/>
@@ -7777,8 +7897,43 @@
           </a:bodyPr>
           <a:lstStyle/>
           <a:p>
+            <a:pPr>
+              <a:defRPr sz="750">
+                <a:solidFill>
+                  <a:srgbClr val="64748B"/>
+                </a:solidFill>
+              </a:defRPr>
+            </a:pPr>
+            <a:r>
+              <a:t>Jira AMSQUAD Sprints 26.04–26.12 · period delivery estimate</a:t>
+            </a:r>
+          </a:p>
+        </p:txBody>
+      </p:sp>
+      <p:sp>
+        <p:nvSpPr>
+          <p:cNvPr id="16" name="TextBox 15"/>
+          <p:cNvSpPr txBox="1"/>
+          <p:nvPr/>
+        </p:nvSpPr>
+        <p:spPr>
+          <a:xfrm>
+            <a:off x="8412480" y="6592824"/>
+            <a:ext cx="548640" cy="201168"/>
+          </a:xfrm>
+          <a:prstGeom prst="rect">
+            <a:avLst/>
+          </a:prstGeom>
+          <a:noFill/>
+        </p:spPr>
+        <p:txBody>
+          <a:bodyPr wrap="none">
+            <a:spAutoFit/>
+          </a:bodyPr>
+          <a:lstStyle/>
+          <a:p>
             <a:pPr algn="r">
-              <a:defRPr sz="900">
+              <a:defRPr sz="800">
                 <a:solidFill>
                   <a:srgbClr val="64748B"/>
                 </a:solidFill>
@@ -8057,7 +8212,7 @@
         <p:spPr>
           <a:xfrm>
             <a:off x="5349240" y="868680"/>
-            <a:ext cx="3474720" cy="5349240"/>
+            <a:ext cx="3474720" cy="5074920"/>
           </a:xfrm>
           <a:prstGeom prst="roundRect">
             <a:avLst/>
@@ -8100,7 +8255,7 @@
         <p:spPr>
           <a:xfrm>
             <a:off x="5349240" y="868680"/>
-            <a:ext cx="54864" cy="5349240"/>
+            <a:ext cx="54864" cy="5074920"/>
           </a:xfrm>
           <a:prstGeom prst="rect">
             <a:avLst/>
@@ -8178,7 +8333,7 @@
         <p:spPr>
           <a:xfrm>
             <a:off x="5532120" y="1307592"/>
-            <a:ext cx="3200400" cy="4846320"/>
+            <a:ext cx="3200400" cy="4572000"/>
           </a:xfrm>
           <a:prstGeom prst="rect">
             <a:avLst/>
@@ -8245,8 +8400,8 @@
         </p:nvSpPr>
         <p:spPr>
           <a:xfrm>
-            <a:off x="0" y="6510528"/>
-            <a:ext cx="9144000" cy="347472"/>
+            <a:off x="0" y="6291072"/>
+            <a:ext cx="9144000" cy="566928"/>
           </a:xfrm>
           <a:prstGeom prst="rect">
             <a:avLst/>
@@ -8288,7 +8443,7 @@
         </p:nvSpPr>
         <p:spPr>
           <a:xfrm>
-            <a:off x="0" y="6510528"/>
+            <a:off x="0" y="6291072"/>
             <a:ext cx="9144000" cy="18288"/>
           </a:xfrm>
           <a:prstGeom prst="rect">
@@ -8331,8 +8486,8 @@
         </p:nvSpPr>
         <p:spPr>
           <a:xfrm>
-            <a:off x="384048" y="6583680"/>
-            <a:ext cx="7772400" cy="228600"/>
+            <a:off x="384048" y="6355080"/>
+            <a:ext cx="8046720" cy="256032"/>
           </a:xfrm>
           <a:prstGeom prst="rect">
             <a:avLst/>
@@ -8346,14 +8501,14 @@
           <a:lstStyle/>
           <a:p>
             <a:pPr>
-              <a:defRPr sz="800">
+              <a:defRPr sz="750" i="1">
                 <a:solidFill>
                   <a:srgbClr val="64748B"/>
                 </a:solidFill>
               </a:defRPr>
             </a:pPr>
             <a:r>
-              <a:t>Jira AMSQUAD export · Sprints 26.04–26.12</a:t>
+              <a:t>Note: Story points = committed sprint work closed. Bugs = defects found via nightly regression triage.</a:t>
             </a:r>
           </a:p>
         </p:txBody>
@@ -8366,8 +8521,8 @@
         </p:nvSpPr>
         <p:spPr>
           <a:xfrm>
-            <a:off x="8412480" y="6583680"/>
-            <a:ext cx="548640" cy="228600"/>
+            <a:off x="384048" y="6592824"/>
+            <a:ext cx="7772400" cy="201168"/>
           </a:xfrm>
           <a:prstGeom prst="rect">
             <a:avLst/>
@@ -8380,8 +8535,43 @@
           </a:bodyPr>
           <a:lstStyle/>
           <a:p>
+            <a:pPr>
+              <a:defRPr sz="750">
+                <a:solidFill>
+                  <a:srgbClr val="64748B"/>
+                </a:solidFill>
+              </a:defRPr>
+            </a:pPr>
+            <a:r>
+              <a:t>Jira AMSQUAD export · Sprints 26.04–26.12</a:t>
+            </a:r>
+          </a:p>
+        </p:txBody>
+      </p:sp>
+      <p:sp>
+        <p:nvSpPr>
+          <p:cNvPr id="16" name="TextBox 15"/>
+          <p:cNvSpPr txBox="1"/>
+          <p:nvPr/>
+        </p:nvSpPr>
+        <p:spPr>
+          <a:xfrm>
+            <a:off x="8412480" y="6592824"/>
+            <a:ext cx="548640" cy="201168"/>
+          </a:xfrm>
+          <a:prstGeom prst="rect">
+            <a:avLst/>
+          </a:prstGeom>
+          <a:noFill/>
+        </p:spPr>
+        <p:txBody>
+          <a:bodyPr wrap="none">
+            <a:spAutoFit/>
+          </a:bodyPr>
+          <a:lstStyle/>
+          <a:p>
             <a:pPr algn="r">
-              <a:defRPr sz="900">
+              <a:defRPr sz="800">
                 <a:solidFill>
                   <a:srgbClr val="64748B"/>
                 </a:solidFill>
@@ -8570,7 +8760,7 @@
               </a:defRPr>
             </a:pPr>
             <a:r>
-              <a:t>V2 Legacy UI — Nightly Snapshot</a:t>
+              <a:t>V2 Legacy UI — Stage1 Nightly Snapshot</a:t>
             </a:r>
           </a:p>
         </p:txBody>
@@ -8644,7 +8834,7 @@
         <p:spPr>
           <a:xfrm>
             <a:off x="320040" y="868680"/>
-            <a:ext cx="4892040" cy="2074988"/>
+            <a:ext cx="4892040" cy="2489524"/>
           </a:xfrm>
           <a:prstGeom prst="rect">
             <a:avLst/>
@@ -8660,7 +8850,7 @@
         <p:spPr>
           <a:xfrm>
             <a:off x="5349240" y="868680"/>
-            <a:ext cx="3474720" cy="5349240"/>
+            <a:ext cx="3474720" cy="5074920"/>
           </a:xfrm>
           <a:prstGeom prst="roundRect">
             <a:avLst/>
@@ -8703,7 +8893,7 @@
         <p:spPr>
           <a:xfrm>
             <a:off x="5349240" y="868680"/>
-            <a:ext cx="54864" cy="5349240"/>
+            <a:ext cx="54864" cy="5074920"/>
           </a:xfrm>
           <a:prstGeom prst="rect">
             <a:avLst/>
@@ -8767,7 +8957,7 @@
               </a:defRPr>
             </a:pPr>
             <a:r>
-              <a:t>V2 inventory</a:t>
+              <a:t>What this counts</a:t>
             </a:r>
           </a:p>
         </p:txBody>
@@ -8781,7 +8971,7 @@
         <p:spPr>
           <a:xfrm>
             <a:off x="5532120" y="1307592"/>
-            <a:ext cx="3200400" cy="4846320"/>
+            <a:ext cx="3200400" cy="4572000"/>
           </a:xfrm>
           <a:prstGeom prst="rect">
             <a:avLst/>
@@ -8805,7 +8995,7 @@
               </a:defRPr>
             </a:pPr>
             <a:r>
-              <a:t>• 592 test methods across 12 modules (Aug 4)</a:t>
+              <a:t>• 592 test methods — Jenkins Stage1 nightly only (Aug 4)</a:t>
             </a:r>
           </a:p>
           <a:p>
@@ -8820,7 +9010,7 @@
               </a:defRPr>
             </a:pPr>
             <a:r>
-              <a:t>• Jenkins Stage1 nightly Mon–Fri</a:t>
+              <a:t>• Built since Q2 2025 — not delivered in Apr–Aug alone</a:t>
             </a:r>
           </a:p>
           <a:p>
@@ -8835,7 +9025,7 @@
               </a:defRPr>
             </a:pPr>
             <a:r>
-              <a:t>• CSR maintenance modules added Apr–Jul</a:t>
+              <a:t>• Bars = methods per module; excludes smoke, Stage 2/5, CSR Actions (+33)</a:t>
             </a:r>
           </a:p>
           <a:p>
@@ -8850,7 +9040,7 @@
               </a:defRPr>
             </a:pPr>
             <a:r>
-              <a:t>• +33 CSR Actions scenarios in next expansion</a:t>
+              <a:t>• CSR maintenance modules added Apr–Jul on top of earlier foundation</a:t>
             </a:r>
           </a:p>
         </p:txBody>
@@ -8863,8 +9053,8 @@
         </p:nvSpPr>
         <p:spPr>
           <a:xfrm>
-            <a:off x="0" y="6510528"/>
-            <a:ext cx="9144000" cy="347472"/>
+            <a:off x="0" y="6291072"/>
+            <a:ext cx="9144000" cy="566928"/>
           </a:xfrm>
           <a:prstGeom prst="rect">
             <a:avLst/>
@@ -8906,7 +9096,7 @@
         </p:nvSpPr>
         <p:spPr>
           <a:xfrm>
-            <a:off x="0" y="6510528"/>
+            <a:off x="0" y="6291072"/>
             <a:ext cx="9144000" cy="18288"/>
           </a:xfrm>
           <a:prstGeom prst="rect">
@@ -8949,8 +9139,8 @@
         </p:nvSpPr>
         <p:spPr>
           <a:xfrm>
-            <a:off x="384048" y="6583680"/>
-            <a:ext cx="7772400" cy="228600"/>
+            <a:off x="384048" y="6355080"/>
+            <a:ext cx="8046720" cy="256032"/>
           </a:xfrm>
           <a:prstGeom prst="rect">
             <a:avLst/>
@@ -8964,14 +9154,14 @@
           <a:lstStyle/>
           <a:p>
             <a:pPr>
-              <a:defRPr sz="800">
+              <a:defRPr sz="750" i="1">
                 <a:solidFill>
                   <a:srgbClr val="64748B"/>
                 </a:solidFill>
               </a:defRPr>
             </a:pPr>
             <a:r>
-              <a:t>Jenkins Stage1 nightly · Aug 4 snapshot</a:t>
+              <a:t>Note: Additional V2 coverage exists outside this snapshot: Stage 5 smoke, Stage 2 smoke, +33 CSR Actions (pending nightly wire), on-demand fast smoke.</a:t>
             </a:r>
           </a:p>
         </p:txBody>
@@ -8984,8 +9174,8 @@
         </p:nvSpPr>
         <p:spPr>
           <a:xfrm>
-            <a:off x="8412480" y="6583680"/>
-            <a:ext cx="548640" cy="228600"/>
+            <a:off x="384048" y="6592824"/>
+            <a:ext cx="7772400" cy="201168"/>
           </a:xfrm>
           <a:prstGeom prst="rect">
             <a:avLst/>
@@ -8998,8 +9188,43 @@
           </a:bodyPr>
           <a:lstStyle/>
           <a:p>
+            <a:pPr>
+              <a:defRPr sz="750">
+                <a:solidFill>
+                  <a:srgbClr val="64748B"/>
+                </a:solidFill>
+              </a:defRPr>
+            </a:pPr>
+            <a:r>
+              <a:t>Jenkins STAGE1-Daily-Unite-Prime-Regression · Aug 4 snapshot</a:t>
+            </a:r>
+          </a:p>
+        </p:txBody>
+      </p:sp>
+      <p:sp>
+        <p:nvSpPr>
+          <p:cNvPr id="16" name="TextBox 15"/>
+          <p:cNvSpPr txBox="1"/>
+          <p:nvPr/>
+        </p:nvSpPr>
+        <p:spPr>
+          <a:xfrm>
+            <a:off x="8412480" y="6592824"/>
+            <a:ext cx="548640" cy="201168"/>
+          </a:xfrm>
+          <a:prstGeom prst="rect">
+            <a:avLst/>
+          </a:prstGeom>
+          <a:noFill/>
+        </p:spPr>
+        <p:txBody>
+          <a:bodyPr wrap="none">
+            <a:spAutoFit/>
+          </a:bodyPr>
+          <a:lstStyle/>
+          <a:p>
             <a:pPr algn="r">
-              <a:defRPr sz="900">
+              <a:defRPr sz="800">
                 <a:solidFill>
                   <a:srgbClr val="64748B"/>
                 </a:solidFill>
@@ -9188,7 +9413,7 @@
               </a:defRPr>
             </a:pPr>
             <a:r>
-              <a:t>V3 Universal Platform — Nightly Snapshot</a:t>
+              <a:t>V3 Universal Platform — Stage1 Nightly Snapshot</a:t>
             </a:r>
           </a:p>
         </p:txBody>
@@ -9262,7 +9487,7 @@
         <p:spPr>
           <a:xfrm>
             <a:off x="320040" y="868680"/>
-            <a:ext cx="4892040" cy="2297850"/>
+            <a:ext cx="4892040" cy="2698766"/>
           </a:xfrm>
           <a:prstGeom prst="rect">
             <a:avLst/>
@@ -9278,7 +9503,7 @@
         <p:spPr>
           <a:xfrm>
             <a:off x="5349240" y="868680"/>
-            <a:ext cx="3474720" cy="5349240"/>
+            <a:ext cx="3474720" cy="5074920"/>
           </a:xfrm>
           <a:prstGeom prst="roundRect">
             <a:avLst/>
@@ -9321,7 +9546,7 @@
         <p:spPr>
           <a:xfrm>
             <a:off x="5349240" y="868680"/>
-            <a:ext cx="54864" cy="5349240"/>
+            <a:ext cx="54864" cy="5074920"/>
           </a:xfrm>
           <a:prstGeom prst="rect">
             <a:avLst/>
@@ -9385,7 +9610,7 @@
               </a:defRPr>
             </a:pPr>
             <a:r>
-              <a:t>V3 inventory</a:t>
+              <a:t>What this counts</a:t>
             </a:r>
           </a:p>
         </p:txBody>
@@ -9399,7 +9624,7 @@
         <p:spPr>
           <a:xfrm>
             <a:off x="5532120" y="1307592"/>
-            <a:ext cx="3200400" cy="4846320"/>
+            <a:ext cx="3200400" cy="4572000"/>
           </a:xfrm>
           <a:prstGeom prst="rect">
             <a:avLst/>
@@ -9423,7 +9648,7 @@
               </a:defRPr>
             </a:pPr>
             <a:r>
-              <a:t>• 442 test methods · UE 303 · IDP 56</a:t>
+              <a:t>• 442 test methods — GitLab Stage1 nightly only (Aug 4)</a:t>
             </a:r>
           </a:p>
           <a:p>
@@ -9438,7 +9663,7 @@
               </a:defRPr>
             </a:pPr>
             <a:r>
-              <a:t>• GitLab CI scheduled regression operational</a:t>
+              <a:t>• Built since Q2 2025 — framework, CI/CD, suites accumulated over ~1 year</a:t>
             </a:r>
           </a:p>
           <a:p>
@@ -9453,7 +9678,22 @@
               </a:defRPr>
             </a:pPr>
             <a:r>
-              <a:t>• Entity suites expanding on separate track</a:t>
+              <a:t>• UE 303 = scenarios × plan/traunch — not 303 unique scripts</a:t>
+            </a:r>
+          </a:p>
+          <a:p>
+            <a:pPr>
+              <a:spcAft>
+                <a:spcPts val="500"/>
+              </a:spcAft>
+              <a:defRPr sz="1000">
+                <a:solidFill>
+                  <a:srgbClr val="1A2332"/>
+                </a:solidFill>
+              </a:defRPr>
+            </a:pPr>
+            <a:r>
+              <a:t>• Entity suites expanding — not all in Aug 4 nightly log</a:t>
             </a:r>
           </a:p>
         </p:txBody>
@@ -9466,8 +9706,8 @@
         </p:nvSpPr>
         <p:spPr>
           <a:xfrm>
-            <a:off x="0" y="6510528"/>
-            <a:ext cx="9144000" cy="347472"/>
+            <a:off x="0" y="6291072"/>
+            <a:ext cx="9144000" cy="566928"/>
           </a:xfrm>
           <a:prstGeom prst="rect">
             <a:avLst/>
@@ -9509,7 +9749,7 @@
         </p:nvSpPr>
         <p:spPr>
           <a:xfrm>
-            <a:off x="0" y="6510528"/>
+            <a:off x="0" y="6291072"/>
             <a:ext cx="9144000" cy="18288"/>
           </a:xfrm>
           <a:prstGeom prst="rect">
@@ -9552,8 +9792,8 @@
         </p:nvSpPr>
         <p:spPr>
           <a:xfrm>
-            <a:off x="384048" y="6583680"/>
-            <a:ext cx="7772400" cy="228600"/>
+            <a:off x="384048" y="6355080"/>
+            <a:ext cx="8046720" cy="256032"/>
           </a:xfrm>
           <a:prstGeom prst="rect">
             <a:avLst/>
@@ -9567,14 +9807,14 @@
           <a:lstStyle/>
           <a:p>
             <a:pPr>
-              <a:defRPr sz="800">
+              <a:defRPr sz="750" i="1">
                 <a:solidFill>
                   <a:srgbClr val="64748B"/>
                 </a:solidFill>
               </a:defRPr>
             </a:pPr>
             <a:r>
-              <a:t>GitLab nightly log · Aug 4 snapshot</a:t>
+              <a:t>Note: Additional V3 coverage exists outside this snapshot: Stage 5 smoke (UE + IDP), integration XML profiles, Entity track — not added to 442.</a:t>
             </a:r>
           </a:p>
         </p:txBody>
@@ -9587,8 +9827,8 @@
         </p:nvSpPr>
         <p:spPr>
           <a:xfrm>
-            <a:off x="8412480" y="6583680"/>
-            <a:ext cx="548640" cy="228600"/>
+            <a:off x="384048" y="6592824"/>
+            <a:ext cx="7772400" cy="201168"/>
           </a:xfrm>
           <a:prstGeom prst="rect">
             <a:avLst/>
@@ -9601,8 +9841,43 @@
           </a:bodyPr>
           <a:lstStyle/>
           <a:p>
+            <a:pPr>
+              <a:defRPr sz="750">
+                <a:solidFill>
+                  <a:srgbClr val="64748B"/>
+                </a:solidFill>
+              </a:defRPr>
+            </a:pPr>
+            <a:r>
+              <a:t>GitLab scheduled_regression_job · Aug 4 snapshot</a:t>
+            </a:r>
+          </a:p>
+        </p:txBody>
+      </p:sp>
+      <p:sp>
+        <p:nvSpPr>
+          <p:cNvPr id="16" name="TextBox 15"/>
+          <p:cNvSpPr txBox="1"/>
+          <p:nvPr/>
+        </p:nvSpPr>
+        <p:spPr>
+          <a:xfrm>
+            <a:off x="8412480" y="6592824"/>
+            <a:ext cx="548640" cy="201168"/>
+          </a:xfrm>
+          <a:prstGeom prst="rect">
+            <a:avLst/>
+          </a:prstGeom>
+          <a:noFill/>
+        </p:spPr>
+        <p:txBody>
+          <a:bodyPr wrap="none">
+            <a:spAutoFit/>
+          </a:bodyPr>
+          <a:lstStyle/>
+          <a:p>
             <a:pPr algn="r">
-              <a:defRPr sz="900">
+              <a:defRPr sz="800">
                 <a:solidFill>
                   <a:srgbClr val="64748B"/>
                 </a:solidFill>
@@ -9881,7 +10156,7 @@
         <p:spPr>
           <a:xfrm>
             <a:off x="5349240" y="868680"/>
-            <a:ext cx="3474720" cy="5349240"/>
+            <a:ext cx="3474720" cy="5074920"/>
           </a:xfrm>
           <a:prstGeom prst="roundRect">
             <a:avLst/>
@@ -9924,7 +10199,7 @@
         <p:spPr>
           <a:xfrm>
             <a:off x="5349240" y="868680"/>
-            <a:ext cx="54864" cy="5349240"/>
+            <a:ext cx="54864" cy="5074920"/>
           </a:xfrm>
           <a:prstGeom prst="rect">
             <a:avLst/>
@@ -10002,7 +10277,7 @@
         <p:spPr>
           <a:xfrm>
             <a:off x="5532120" y="1307592"/>
-            <a:ext cx="3200400" cy="4846320"/>
+            <a:ext cx="3200400" cy="4572000"/>
           </a:xfrm>
           <a:prstGeom prst="rect">
             <a:avLst/>
@@ -10026,7 +10301,7 @@
               </a:defRPr>
             </a:pPr>
             <a:r>
-              <a:t>• M2 25/25 endpoints · M1 ~25/29 core</a:t>
+              <a:t>• M2 25/25 endpoints · M1 ~25/29 core categories</a:t>
             </a:r>
           </a:p>
           <a:p>
@@ -10084,8 +10359,8 @@
         </p:nvSpPr>
         <p:spPr>
           <a:xfrm>
-            <a:off x="0" y="6510528"/>
-            <a:ext cx="9144000" cy="347472"/>
+            <a:off x="0" y="6291072"/>
+            <a:ext cx="9144000" cy="566928"/>
           </a:xfrm>
           <a:prstGeom prst="rect">
             <a:avLst/>
@@ -10127,7 +10402,7 @@
         </p:nvSpPr>
         <p:spPr>
           <a:xfrm>
-            <a:off x="0" y="6510528"/>
+            <a:off x="0" y="6291072"/>
             <a:ext cx="9144000" cy="18288"/>
           </a:xfrm>
           <a:prstGeom prst="rect">
@@ -10170,8 +10445,8 @@
         </p:nvSpPr>
         <p:spPr>
           <a:xfrm>
-            <a:off x="384048" y="6583680"/>
-            <a:ext cx="7772400" cy="228600"/>
+            <a:off x="384048" y="6355080"/>
+            <a:ext cx="8046720" cy="256032"/>
           </a:xfrm>
           <a:prstGeom prst="rect">
             <a:avLst/>
@@ -10185,14 +10460,14 @@
           <a:lstStyle/>
           <a:p>
             <a:pPr>
-              <a:defRPr sz="800">
+              <a:defRPr sz="750" i="1">
                 <a:solidFill>
                   <a:srgbClr val="64748B"/>
                 </a:solidFill>
               </a:defRPr>
             </a:pPr>
             <a:r>
-              <a:t>api-test-automation repo inventory</a:t>
+              <a:t>Note: M2 = full mobile endpoint catalog. M1 ~86% of 29 core categories — master suite still in progress.</a:t>
             </a:r>
           </a:p>
         </p:txBody>
@@ -10205,8 +10480,8 @@
         </p:nvSpPr>
         <p:spPr>
           <a:xfrm>
-            <a:off x="8412480" y="6583680"/>
-            <a:ext cx="548640" cy="228600"/>
+            <a:off x="384048" y="6592824"/>
+            <a:ext cx="7772400" cy="201168"/>
           </a:xfrm>
           <a:prstGeom prst="rect">
             <a:avLst/>
@@ -10219,8 +10494,43 @@
           </a:bodyPr>
           <a:lstStyle/>
           <a:p>
+            <a:pPr>
+              <a:defRPr sz="750">
+                <a:solidFill>
+                  <a:srgbClr val="64748B"/>
+                </a:solidFill>
+              </a:defRPr>
+            </a:pPr>
+            <a:r>
+              <a:t>api-test-automation repo inventory</a:t>
+            </a:r>
+          </a:p>
+        </p:txBody>
+      </p:sp>
+      <p:sp>
+        <p:nvSpPr>
+          <p:cNvPr id="16" name="TextBox 15"/>
+          <p:cNvSpPr txBox="1"/>
+          <p:nvPr/>
+        </p:nvSpPr>
+        <p:spPr>
+          <a:xfrm>
+            <a:off x="8412480" y="6592824"/>
+            <a:ext cx="548640" cy="201168"/>
+          </a:xfrm>
+          <a:prstGeom prst="rect">
+            <a:avLst/>
+          </a:prstGeom>
+          <a:noFill/>
+        </p:spPr>
+        <p:txBody>
+          <a:bodyPr wrap="none">
+            <a:spAutoFit/>
+          </a:bodyPr>
+          <a:lstStyle/>
+          <a:p>
             <a:pPr algn="r">
-              <a:defRPr sz="900">
+              <a:defRPr sz="800">
                 <a:solidFill>
                   <a:srgbClr val="64748B"/>
                 </a:solidFill>
@@ -10483,7 +10793,7 @@
         <p:spPr>
           <a:xfrm>
             <a:off x="320040" y="868680"/>
-            <a:ext cx="4892040" cy="2210826"/>
+            <a:ext cx="4892040" cy="2723375"/>
           </a:xfrm>
           <a:prstGeom prst="rect">
             <a:avLst/>
@@ -10499,7 +10809,7 @@
         <p:spPr>
           <a:xfrm>
             <a:off x="5349240" y="868680"/>
-            <a:ext cx="3474720" cy="5349240"/>
+            <a:ext cx="3474720" cy="5074920"/>
           </a:xfrm>
           <a:prstGeom prst="roundRect">
             <a:avLst/>
@@ -10542,7 +10852,7 @@
         <p:spPr>
           <a:xfrm>
             <a:off x="5349240" y="868680"/>
-            <a:ext cx="54864" cy="5349240"/>
+            <a:ext cx="54864" cy="5074920"/>
           </a:xfrm>
           <a:prstGeom prst="rect">
             <a:avLst/>
@@ -10620,7 +10930,7 @@
         <p:spPr>
           <a:xfrm>
             <a:off x="5532120" y="1307592"/>
-            <a:ext cx="3200400" cy="4846320"/>
+            <a:ext cx="3200400" cy="4572000"/>
           </a:xfrm>
           <a:prstGeom prst="rect">
             <a:avLst/>
@@ -10644,7 +10954,7 @@
               </a:defRPr>
             </a:pPr>
             <a:r>
-              <a:t>• 323 test cases = labels × plan permutations</a:t>
+              <a:t>• 83 base transaction flows → 323 plan-expanded cases</a:t>
             </a:r>
           </a:p>
           <a:p>
@@ -10659,7 +10969,7 @@
               </a:defRPr>
             </a:pPr>
             <a:r>
-              <a:t>• IDP: 15 labels × 7 plans · legacy × 5 plans</a:t>
+              <a:t>• Bars = flows; line = cases after × plan matrix</a:t>
             </a:r>
           </a:p>
           <a:p>
@@ -10674,7 +10984,7 @@
               </a:defRPr>
             </a:pPr>
             <a:r>
-              <a:t>• 4 Jenkins scenarios — not the same as test case count</a:t>
+              <a:t>• IDP: 15 labels × 7 plans = 105 cases alone</a:t>
             </a:r>
           </a:p>
           <a:p>
@@ -10702,8 +11012,8 @@
         </p:nvSpPr>
         <p:spPr>
           <a:xfrm>
-            <a:off x="0" y="6510528"/>
-            <a:ext cx="9144000" cy="347472"/>
+            <a:off x="0" y="6291072"/>
+            <a:ext cx="9144000" cy="566928"/>
           </a:xfrm>
           <a:prstGeom prst="rect">
             <a:avLst/>
@@ -10745,7 +11055,7 @@
         </p:nvSpPr>
         <p:spPr>
           <a:xfrm>
-            <a:off x="0" y="6510528"/>
+            <a:off x="0" y="6291072"/>
             <a:ext cx="9144000" cy="18288"/>
           </a:xfrm>
           <a:prstGeom prst="rect">
@@ -10788,8 +11098,8 @@
         </p:nvSpPr>
         <p:spPr>
           <a:xfrm>
-            <a:off x="384048" y="6583680"/>
-            <a:ext cx="7772400" cy="228600"/>
+            <a:off x="384048" y="6355080"/>
+            <a:ext cx="8046720" cy="256032"/>
           </a:xfrm>
           <a:prstGeom prst="rect">
             <a:avLst/>
@@ -10803,14 +11113,14 @@
           <a:lstStyle/>
           <a:p>
             <a:pPr>
-              <a:defRPr sz="800">
+              <a:defRPr sz="750" i="1">
                 <a:solidFill>
                   <a:srgbClr val="64748B"/>
                 </a:solidFill>
               </a:defRPr>
             </a:pPr>
             <a:r>
-              <a:t>Perf inventory model · Jenkins + BlazeMeter</a:t>
+              <a:t>Note: 4 Jenkins scenarios schedule runs — not 323 separate jobs. Plan expansion is standard perf counting.</a:t>
             </a:r>
           </a:p>
         </p:txBody>
@@ -10823,8 +11133,8 @@
         </p:nvSpPr>
         <p:spPr>
           <a:xfrm>
-            <a:off x="8412480" y="6583680"/>
-            <a:ext cx="548640" cy="228600"/>
+            <a:off x="384048" y="6592824"/>
+            <a:ext cx="7772400" cy="201168"/>
           </a:xfrm>
           <a:prstGeom prst="rect">
             <a:avLst/>
@@ -10837,8 +11147,43 @@
           </a:bodyPr>
           <a:lstStyle/>
           <a:p>
+            <a:pPr>
+              <a:defRPr sz="750">
+                <a:solidFill>
+                  <a:srgbClr val="64748B"/>
+                </a:solidFill>
+              </a:defRPr>
+            </a:pPr>
+            <a:r>
+              <a:t>Perf inventory model · Jenkins + BlazeMeter</a:t>
+            </a:r>
+          </a:p>
+        </p:txBody>
+      </p:sp>
+      <p:sp>
+        <p:nvSpPr>
+          <p:cNvPr id="16" name="TextBox 15"/>
+          <p:cNvSpPr txBox="1"/>
+          <p:nvPr/>
+        </p:nvSpPr>
+        <p:spPr>
+          <a:xfrm>
+            <a:off x="8412480" y="6592824"/>
+            <a:ext cx="548640" cy="201168"/>
+          </a:xfrm>
+          <a:prstGeom prst="rect">
+            <a:avLst/>
+          </a:prstGeom>
+          <a:noFill/>
+        </p:spPr>
+        <p:txBody>
+          <a:bodyPr wrap="none">
+            <a:spAutoFit/>
+          </a:bodyPr>
+          <a:lstStyle/>
+          <a:p>
             <a:pPr algn="r">
-              <a:defRPr sz="900">
+              <a:defRPr sz="800">
                 <a:solidFill>
                   <a:srgbClr val="64748B"/>
                 </a:solidFill>

</xml_diff>